<commit_message>
Legacy bug plans: v0.9.0 plans written out, L131 effect, new bug L230
- tools/gen_G.py rewrites 33 v0.9.0 plans cell by cell from the 465 file
  (118 entries); only L224, a change of method, stays described.
- L230 registered with its plan: the electricity current carbon tax and
  ETS outputs (results 16236-16251) never see the existing carbon price.
- Register text: L131 value effect (results 17161/17163), L129/L132/L133
  locations. Shared 465 reader in tools/xlsb465.py.
- Regenerated in place: BUGS.md, tracker, bugs document, register JSON,
  Documentation, Methods; counts 227 -> 228 patched in the deck, website
  page and QuickStart.

Co-Authored-By: Claude Opus 5.5 <noreply@anthropic.com>
Claude-Session: https://claude.ai/code/session_01VSHkeKLNKwtFiko3pymStx
</commit_message>
<xml_diff>
--- a/excel_ai/CPAT-AI_Overview_v1.0.0.pptx
+++ b/excel_ai/CPAT-AI_Overview_v1.0.0.pptx
@@ -7622,7 +7622,7 @@
                   <a:srgbClr val="FFFFFF"/>
                 </a:solidFill>
               </a:rPr>
-              <a:t>227 legacy bugs found</a:t>
+              <a:t>228 legacy bugs found</a:t>
             </a:r>
             <a:endParaRPr lang="en-US" sz="1300" dirty="0"/>
           </a:p>
@@ -11403,7 +11403,7 @@
                 <a:ea typeface="Cambria" pitchFamily="34" charset="-122"/>
                 <a:cs typeface="Cambria" pitchFamily="34" charset="-120"/>
               </a:rPr>
-              <a:t>227</a:t>
+              <a:t>228</a:t>
             </a:r>
             <a:endParaRPr lang="en-US" sz="4000" dirty="0"/>
           </a:p>
@@ -13898,7 +13898,7 @@
                 <a:ea typeface="Cambria" pitchFamily="34" charset="-122"/>
                 <a:cs typeface="Cambria" pitchFamily="34" charset="-120"/>
               </a:rPr>
-              <a:t>227</a:t>
+              <a:t>228</a:t>
             </a:r>
             <a:endParaRPr lang="en-US" sz="4000" dirty="0"/>
           </a:p>
@@ -13912,7 +13912,7 @@
                   <a:srgbClr val="5C667A"/>
                 </a:solidFill>
               </a:rPr>
-              <a:t>legacy bugs found (196 mitigation, 31 distribution), none replicated</a:t>
+              <a:t>legacy bugs found (197 mitigation, 31 distribution), none replicated</a:t>
             </a:r>
             <a:endParaRPr lang="en-US" sz="4000" dirty="0"/>
           </a:p>
@@ -15373,7 +15373,7 @@
                 <a:ea typeface="Cambria" pitchFamily="34" charset="-122"/>
                 <a:cs typeface="Cambria" pitchFamily="34" charset="-120"/>
               </a:rPr>
-              <a:t>227 bugs found in legacy CPAT; 24 of high priority</a:t>
+              <a:t>228 bugs found in legacy CPAT; 24 of high priority</a:t>
             </a:r>
             <a:endParaRPr lang="en-US" sz="3000" dirty="0"/>
           </a:p>
@@ -16734,7 +16734,7 @@
                 <a:ea typeface="Cambria" pitchFamily="34" charset="-122"/>
                 <a:cs typeface="Cambria" pitchFamily="34" charset="-120"/>
               </a:rPr>
-              <a:t>110 + 31</a:t>
+              <a:t>111 + 31</a:t>
             </a:r>
             <a:endParaRPr lang="en-US" sz="4000" dirty="0"/>
           </a:p>
@@ -16784,7 +16784,7 @@
                   <a:srgbClr val="5C667A"/>
                 </a:solidFill>
               </a:rPr>
-              <a:t>196 mitigation and 31 distribution bugs, all fixed in the prototype; also 135 legacy issues (126 mitigation, 9 distribution), replicated and tracked. Fix plans: Legacy_CPAT_Bugs_v1.0.0.docx. Legacy CPAT 1.0pre_465: the CPAT team marked 63 fixed (52 confirmed, 9 with caveats, 2 not fixed).</a:t>
+              <a:t>197 mitigation and 31 distribution bugs, all fixed in the prototype; also 135 legacy issues (126 mitigation, 9 distribution), replicated and tracked. Fix plans: Legacy_CPAT_Bugs_v1.0.0.docx. Legacy CPAT 1.0pre_465: the CPAT team marked 63 fixed (52 confirmed, 9 with caveats, 2 not fixed).</a:t>
             </a:r>
             <a:endParaRPr lang="en-US" sz="1200" dirty="0"/>
           </a:p>

</xml_diff>